<commit_message>
Use lesson metadata in eight-slide decks
</commit_message>
<xml_diff>
--- a/uganda-p7-mvp/p7_t1_mathematics_1205/p7_t1_mathematics_1205.pptx
+++ b/uganda-p7-mvp/p7_t1_mathematics_1205/p7_t1_mathematics_1205.pptx
@@ -3120,7 +3120,7 @@
             <a:pPr algn="ctr"/>
             <a:r>
               <a:rPr sz="3400" b="1"/>
-              <a:t>4.2 Number patterns and sequence / Term 1 Review</a:t>
+              <a:t>4.0 Patterns and Sequences (Final Review)</a:t>
             </a:r>
           </a:p>
         </p:txBody>
@@ -3157,14 +3157,21 @@
             <a:pPr algn="ctr"/>
             <a:r>
               <a:rPr sz="2200"/>
-              <a:t>The learner forms subsets and represents information using concrete objects from the</a:t>
+              <a:t>By the end of the lesson, learners will be able to apply all Term 1 mathematical</a:t>
             </a:r>
           </a:p>
           <a:p>
             <a:pPr algn="ctr"/>
             <a:r>
               <a:rPr sz="2200"/>
-              <a:t>local environment.</a:t>
+              <a:t>concepts (Sets, Whole Numbers, Operations, Patterns) to complete a comprehensive</a:t>
+            </a:r>
+          </a:p>
+          <a:p>
+            <a:pPr algn="ctr"/>
+            <a:r>
+              <a:rPr sz="2200"/>
+              <a:t>"Math Mastery Project" simulating a local market scenario.</a:t>
             </a:r>
           </a:p>
         </p:txBody>
@@ -3245,7 +3252,7 @@
               <a:defRPr sz="2200"/>
             </a:pPr>
             <a:r>
-              <a:t>The learner forms subsets and represents information using concrete objects from the</a:t>
+              <a:t>By the end of the lesson, learners will be able to apply all Term 1 mathematical</a:t>
             </a:r>
           </a:p>
           <a:p>
@@ -3256,7 +3263,7 @@
               <a:defRPr sz="2200"/>
             </a:pPr>
             <a:r>
-              <a:t>local environment.</a:t>
+              <a:t>concepts (Sets, Whole Numbers, Operations, Patterns) to complete a comprehensive</a:t>
             </a:r>
           </a:p>
           <a:p>
@@ -3267,7 +3274,18 @@
               <a:defRPr sz="2200"/>
             </a:pPr>
             <a:r>
-              <a:t>Lesson focus: 4.2 Number patterns and sequence / Term 1 Review</a:t>
+              <a:t>"Math Mastery Project" simulating a local market scenario.</a:t>
+            </a:r>
+          </a:p>
+          <a:p>
+            <a:pPr>
+              <a:spcAft>
+                <a:spcPts val="800"/>
+              </a:spcAft>
+              <a:defRPr sz="2200"/>
+            </a:pPr>
+            <a:r>
+              <a:t>Lesson focus: 4.0 Patterns and Sequences (Final Review)</a:t>
             </a:r>
           </a:p>
         </p:txBody>

</xml_diff>